<commit_message>
Update project presentation and summary deliverables
Refresh the PowerPoint presentation and project summary, along with their corresponding PDF exports.
</commit_message>
<xml_diff>
--- a/Cairnly_Assistant_OLLM_Project1_GroupA.pptx
+++ b/Cairnly_Assistant_OLLM_Project1_GroupA.pptx
@@ -670,7 +670,7 @@
                 <a:uFillTx/>
                 <a:latin typeface="Arial"/>
               </a:rPr>
-              <a:t>Recurring questions include shipping, returns and order status. Every message gets one of 7 categories and an urgency level (low, medium, high). Both data sources were authored by the group for the assignment and contain no real personal data: 25 Help Centre documents and 5 invented orders in a read-only SQLite database. Demonstrate an FAQ question and a status lookup; explain that the current restrictions are design choices, not deployable privacy guarantees.</a:t>
+              <a:t>Recurring questions include shipping, returns and order status. Every message gets one of 7 categories and an urgency level (low, medium, high). Both data sources were authored by the group for the assignment and contain no real personal data: 25 Help Centre documents and 5 invented orders in a read-only SQLite database. The orders table contains example e-mail addresses, but the bot does not use them: the order number alone is enough for a lookup. Demonstrate an FAQ question and a status lookup; explain that the current restrictions are design choices, not deployable privacy guarantees.</a:t>
             </a:r>
             <a:endParaRPr lang="en-US" sz="2000" b="0" u="none" strike="noStrike">
               <a:solidFill>
@@ -1398,7 +1398,7 @@
                 <a:uFillTx/>
                 <a:latin typeface="Arial"/>
               </a:rPr>
-              <a:t>Be explicit: there are real privacy, safety, and reliability gaps. Any order number can retrieve status, card masking is incomplete (CVV and expiry stay visible) and the attack filter only matches known phrases. Blocked messages still stay in the conversation history. There is no human hand-off. If an API error persists after the Groq SDK’s two default retries, the reply stays empty. Group A Project 2 asks for systematic red-teaming and at least one evaluated safeguard. Proposed improvements are next steps, not implemented features.</a:t>
+              <a:t>Be explicit: there are real privacy, safety, and reliability gaps. Any order number can retrieve status, and the order-number format is not validated before the lookup. Card masking is incomplete (CVV and expiry stay visible), and the phone regex also masks dates such as 2026-10-12. The attack filter only matches a fixed list of 9 known phrases, and tag stripping is a single regex pass, so nested tags can rebuild a delimiter tag. Retrieval has no similarity threshold, so the top 3 documents are always sent even when none is relevant, and there is no limit on tool calls per turn. Blocked messages still stay in the conversation history. If an API error persists after the Groq SDK’s two default retries, the reply stays empty. Group A Project 2 asks for systematic red-teaming and at least one evaluated safeguard. Proposed improvements are next steps, not implemented features.</a:t>
             </a:r>
             <a:endParaRPr lang="en-US" sz="2000" b="0" u="none" strike="noStrike">
               <a:solidFill>
@@ -9437,7 +9437,7 @@
                 <a:latin typeface="Arial"/>
                 <a:ea typeface="DejaVu Sans"/>
               </a:rPr>
-              <a:t>Conditional tool: the model may call one fixed, parameterised, read-only SQLite order lookup (no writes).</a:t>
+              <a:t>Conditional tool: one fixed, read-only SQLite lookup by order number only (no e-mail needed, no writes).</a:t>
             </a:r>
             <a:endParaRPr lang="en-US" sz="1700" b="0" u="none" strike="noStrike">
               <a:solidFill>
@@ -12716,7 +12716,7 @@
                 <a:latin typeface="Arial"/>
                 <a:ea typeface="DejaVu Sans"/>
               </a:rPr>
-              <a:t>An order number reveals status; CVV and expiry are not masked.</a:t>
+              <a:t>Order number alone reveals status; CVV and expiry are not masked.</a:t>
             </a:r>
             <a:endParaRPr lang="en-US" sz="1600" b="0" u="none" strike="noStrike">
               <a:solidFill>
@@ -12832,7 +12832,7 @@
                 <a:latin typeface="Arial"/>
                 <a:ea typeface="DejaVu Sans"/>
               </a:rPr>
-              <a:t>Known-phrase attack filters, no handoff; answers may vary.</a:t>
+              <a:t>Fixed list of 9 attack phrases; nested tags bypass tag stripping.</a:t>
             </a:r>
             <a:endParaRPr lang="en-US" sz="1600" b="0" u="none" strike="noStrike">
               <a:solidFill>
@@ -12890,7 +12890,7 @@
                 <a:latin typeface="Arial"/>
                 <a:ea typeface="DejaVu Sans"/>
               </a:rPr>
-              <a:t>OPERATIONS</a:t>
+              <a:t>RETRIEVAL &amp; TOOL</a:t>
             </a:r>
             <a:endParaRPr lang="en-US" sz="1400" b="0" u="none" strike="noStrike">
               <a:solidFill>
@@ -12948,7 +12948,7 @@
                 <a:latin typeface="Arial"/>
                 <a:ea typeface="DejaVu Sans"/>
               </a:rPr>
-              <a:t>Free tier with rate limits; order lookups take 16–24 s (2 LLM calls).</a:t>
+              <a:t>No similarity threshold: top 3 always sent; no tool-call limit.</a:t>
             </a:r>
             <a:endParaRPr lang="en-US" sz="1600" b="0" u="none" strike="noStrike">
               <a:solidFill>

</xml_diff>

<commit_message>
Update project presentation deliverables
Refresh the PowerPoint presentation and its PDF export.
</commit_message>
<xml_diff>
--- a/Cairnly_Assistant_OLLM_Project1_GroupA.pptx
+++ b/Cairnly_Assistant_OLLM_Project1_GroupA.pptx
@@ -19,6 +19,7 @@
     <p:sldId id="259" r:id="rId12"/>
     <p:sldId id="260" r:id="rId13"/>
     <p:sldId id="261" r:id="rId14"/>
+    <p:sldId id="262" r:id="rId16"/>
   </p:sldIdLst>
   <p:sldSz cx="12192000" cy="6858000"/>
   <p:notesSz cx="7772400" cy="10058400"/>
@@ -1491,6 +1492,76 @@
       </p:sp>
     </p:spTree>
   </p:cSld>
+</p:notes>
+</file>
+
+<file path=ppt/notesSlides/notesSlide7.xml><?xml version="1.0" encoding="utf-8"?>
+<p:notes xmlns:a="http://schemas.openxmlformats.org/drawingml/2006/main" xmlns:p="http://schemas.openxmlformats.org/presentationml/2006/main" xmlns:r="http://schemas.openxmlformats.org/officeDocument/2006/relationships">
+  <p:cSld>
+    <p:spTree>
+      <p:nvGrpSpPr>
+        <p:cNvPr id="1" name=""/>
+        <p:cNvGrpSpPr/>
+        <p:nvPr/>
+      </p:nvGrpSpPr>
+      <p:grpSpPr>
+        <a:xfrm>
+          <a:off x="0" y="0"/>
+          <a:ext cx="0" cy="0"/>
+          <a:chOff x="0" y="0"/>
+          <a:chExt cx="0" cy="0"/>
+        </a:xfrm>
+      </p:grpSpPr>
+      <p:sp>
+        <p:nvSpPr>
+          <p:cNvPr id="2" name="Slide Image Placeholder 1"/>
+          <p:cNvSpPr>
+            <a:spLocks noGrp="1"/>
+          </p:cNvSpPr>
+          <p:nvPr>
+            <p:ph type="sldImg"/>
+          </p:nvPr>
+        </p:nvSpPr>
+        <p:spPr/>
+      </p:sp>
+      <p:sp>
+        <p:nvSpPr>
+          <p:cNvPr id="3" name="Notes Placeholder 2"/>
+          <p:cNvSpPr>
+            <a:spLocks noGrp="1"/>
+          </p:cNvSpPr>
+          <p:nvPr>
+            <p:ph type="body"/>
+          </p:nvPr>
+        </p:nvSpPr>
+        <p:spPr/>
+        <p:txBody>
+          <a:bodyPr/>
+          <a:lstStyle/>
+          <a:p>
+            <a:r>
+              <a:t>Appendix / backup slide, beyond the 6-slide main deck; show it only if there is time or a question about the demo. Left: an earlier prototype from 16 October (commit 7e9594d), run in the Jupyter notebook. Settings then: temperature 0.2, a maximum of 1,000 completion tokens, and the order lookup required the customer's e-mail address (the tool first returned 'verification_required'). After the customer gave the e-mail, the model got stuck in a repetition loop; the 1,000-token cap truncated the output before the JSON closed, so it could not be parsed and the category and urgency came out as None. The next commit (7053af0) raised the cap to 2,500 tokens and removed the e-mail check, so the order number alone is now enough. Temperature is still 0.2 today, so the fix was the token cap, not the temperature. Right: the current version in the Streamlit web chat. The same conversation mixes Hungarian, Finnish and English, and each reply follows the language of the customer's latest message because of a rule in the prompt. The multilingual e5 embeddings retrieve the right Help Centre documents across languages, e.g. the 30-day free returns policy for the Finnish question, and the order lookup (A1001, already shipped) works without an e-mail address.</a:t>
+            </a:r>
+          </a:p>
+        </p:txBody>
+      </p:sp>
+      <p:sp>
+        <p:nvSpPr>
+          <p:cNvPr id="4" name="Slide Number Placeholder 3"/>
+          <p:cNvSpPr>
+            <a:spLocks noGrp="1"/>
+          </p:cNvSpPr>
+          <p:nvPr>
+            <p:ph type="sldNum" idx="8"/>
+          </p:nvPr>
+        </p:nvSpPr>
+        <p:spPr/>
+      </p:sp>
+    </p:spTree>
+  </p:cSld>
+  <p:clrMapOvr>
+    <a:masterClrMapping/>
+  </p:clrMapOvr>
 </p:notes>
 </file>
 
@@ -13293,6 +13364,473 @@
       <p:transition spd="slow"/>
     </mc:Fallback>
   </mc:AlternateContent>
+</p:sld>
+</file>
+
+<file path=ppt/slides/slide7.xml><?xml version="1.0" encoding="utf-8"?>
+<p:sld xmlns:a="http://schemas.openxmlformats.org/drawingml/2006/main" xmlns:p="http://schemas.openxmlformats.org/presentationml/2006/main" xmlns:r="http://schemas.openxmlformats.org/officeDocument/2006/relationships">
+  <p:cSld>
+    <p:spTree>
+      <p:nvGrpSpPr>
+        <p:cNvPr id="1" name=""/>
+        <p:cNvGrpSpPr/>
+        <p:nvPr/>
+      </p:nvGrpSpPr>
+      <p:grpSpPr/>
+      <p:sp>
+        <p:nvSpPr>
+          <p:cNvPr id="62" name="Title"/>
+          <p:cNvSpPr/>
+          <p:nvPr/>
+        </p:nvSpPr>
+        <p:spPr>
+          <a:xfrm>
+            <a:off x="594360" y="475560"/>
+            <a:ext cx="10926360" cy="518040"/>
+          </a:xfrm>
+          <a:prstGeom prst="rect">
+            <a:avLst/>
+          </a:prstGeom>
+          <a:noFill/>
+          <a:ln w="0">
+            <a:noFill/>
+          </a:ln>
+        </p:spPr>
+        <p:style>
+          <a:lnRef idx="0"/>
+          <a:fillRef idx="0"/>
+          <a:effectRef idx="0"/>
+          <a:fontRef idx="minor"/>
+        </p:style>
+        <p:txBody>
+          <a:bodyPr lIns="0" tIns="0" rIns="0" bIns="0" anchor="t">
+            <a:spAutoFit/>
+          </a:bodyPr>
+          <a:p>
+            <a:pPr defTabSz="914400">
+              <a:lnSpc>
+                <a:spcPct val="100000"/>
+              </a:lnSpc>
+            </a:pPr>
+            <a:r>
+              <a:rPr lang="hu-HU" sz="3400" b="1" u="none" strike="noStrike">
+                <a:solidFill>
+                  <a:srgbClr val="221818"/>
+                </a:solidFill>
+                <a:effectLst/>
+                <a:uFillTx/>
+                <a:latin typeface="Arial"/>
+                <a:ea typeface="DejaVu Sans"/>
+              </a:rPr>
+              <a:t>Appendix: demo examples</a:t>
+            </a:r>
+            <a:endParaRPr lang="en-US" sz="3400" b="0" u="none" strike="noStrike">
+              <a:solidFill>
+                <a:srgbClr val="000000"/>
+              </a:solidFill>
+              <a:effectLst/>
+              <a:uFillTx/>
+              <a:latin typeface="Arial"/>
+            </a:endParaRPr>
+          </a:p>
+        </p:txBody>
+      </p:sp>
+      <p:sp>
+        <p:nvSpPr>
+          <p:cNvPr id="63" name="Accent underline"/>
+          <p:cNvSpPr/>
+          <p:nvPr/>
+        </p:nvSpPr>
+        <p:spPr>
+          <a:xfrm>
+            <a:off x="621720" y="1124640"/>
+            <a:ext cx="1050840" cy="49680"/>
+          </a:xfrm>
+          <a:prstGeom prst="rect">
+            <a:avLst/>
+          </a:prstGeom>
+          <a:solidFill>
+            <a:srgbClr val="FF3E31"/>
+          </a:solidFill>
+          <a:ln w="6480">
+            <a:noFill/>
+          </a:ln>
+        </p:spPr>
+        <p:style>
+          <a:lnRef idx="0"/>
+          <a:fillRef idx="0"/>
+          <a:effectRef idx="0"/>
+          <a:fontRef idx="minor"/>
+        </p:style>
+        <p:txBody>
+          <a:bodyPr lIns="90000" tIns="5400" rIns="90000" bIns="5400" anchor="ctr">
+            <a:noAutofit/>
+          </a:bodyPr>
+          <a:p>
+            <a:endParaRPr lang="hu-HU" sz="1800" b="0" u="none" strike="noStrike">
+              <a:solidFill>
+                <a:schemeClr val="lt1"/>
+              </a:solidFill>
+              <a:effectLst/>
+              <a:uFillTx/>
+              <a:latin typeface="Arial"/>
+            </a:endParaRPr>
+          </a:p>
+        </p:txBody>
+      </p:sp>
+      <p:sp>
+        <p:nvSpPr>
+          <p:cNvPr id="76" name="Page number"/>
+          <p:cNvSpPr/>
+          <p:nvPr/>
+        </p:nvSpPr>
+        <p:spPr>
+          <a:xfrm>
+            <a:off x="11503080" y="6108120"/>
+            <a:ext cx="273600" cy="198360"/>
+          </a:xfrm>
+          <a:prstGeom prst="rect">
+            <a:avLst/>
+          </a:prstGeom>
+          <a:noFill/>
+          <a:ln w="0">
+            <a:noFill/>
+          </a:ln>
+        </p:spPr>
+        <p:style>
+          <a:lnRef idx="0"/>
+          <a:fillRef idx="0"/>
+          <a:effectRef idx="0"/>
+          <a:fontRef idx="minor"/>
+        </p:style>
+        <p:txBody>
+          <a:bodyPr lIns="0" tIns="0" rIns="0" bIns="0" anchor="t">
+            <a:spAutoFit/>
+          </a:bodyPr>
+          <a:p>
+            <a:pPr algn="r" defTabSz="914400">
+              <a:lnSpc>
+                <a:spcPct val="100000"/>
+              </a:lnSpc>
+            </a:pPr>
+            <a:r>
+              <a:rPr lang="hu-HU" sz="1300" b="0" u="none" strike="noStrike">
+                <a:solidFill>
+                  <a:srgbClr val="3A0302"/>
+                </a:solidFill>
+                <a:effectLst/>
+                <a:uFillTx/>
+                <a:latin typeface="Arial"/>
+                <a:ea typeface="DejaVu Sans"/>
+              </a:rPr>
+              <a:t>7</a:t>
+            </a:r>
+            <a:endParaRPr lang="en-US" sz="1300" b="0" u="none" strike="noStrike">
+              <a:solidFill>
+                <a:srgbClr val="000000"/>
+              </a:solidFill>
+              <a:effectLst/>
+              <a:uFillTx/>
+              <a:latin typeface="Arial"/>
+            </a:endParaRPr>
+          </a:p>
+        </p:txBody>
+      </p:sp>
+      <p:sp>
+        <p:nvSpPr>
+          <p:cNvPr id="141" name="Heading left"/>
+          <p:cNvSpPr/>
+          <p:nvPr/>
+        </p:nvSpPr>
+        <p:spPr>
+          <a:xfrm>
+            <a:off x="594360" y="1371600"/>
+            <a:ext cx="5755568" cy="213480"/>
+          </a:xfrm>
+          <a:prstGeom prst="rect">
+            <a:avLst/>
+          </a:prstGeom>
+          <a:noFill/>
+          <a:ln w="0">
+            <a:noFill/>
+          </a:ln>
+        </p:spPr>
+        <p:style>
+          <a:lnRef idx="0"/>
+          <a:fillRef idx="0"/>
+          <a:effectRef idx="0"/>
+          <a:fontRef idx="minor"/>
+        </p:style>
+        <p:txBody>
+          <a:bodyPr lIns="0" tIns="0" rIns="0" bIns="0" anchor="t">
+            <a:spAutoFit/>
+          </a:bodyPr>
+          <a:p>
+            <a:pPr defTabSz="914400">
+              <a:lnSpc>
+                <a:spcPct val="100000"/>
+              </a:lnSpc>
+            </a:pPr>
+            <a:r>
+              <a:rPr lang="hu-HU" sz="1400" b="1" u="none" strike="noStrike">
+                <a:solidFill>
+                  <a:srgbClr val="FF3E31"/>
+                </a:solidFill>
+                <a:effectLst/>
+                <a:uFillTx/>
+                <a:latin typeface="Arial"/>
+                <a:ea typeface="DejaVu Sans"/>
+              </a:rPr>
+              <a:t>EARLIER PROTOTYPE (16 OCT)</a:t>
+            </a:r>
+            <a:endParaRPr lang="en-US" sz="1400" b="0" u="none" strike="noStrike">
+              <a:solidFill>
+                <a:srgbClr val="FFFFFF"/>
+              </a:solidFill>
+              <a:effectLst/>
+              <a:uFillTx/>
+              <a:latin typeface="Arial"/>
+            </a:endParaRPr>
+          </a:p>
+        </p:txBody>
+      </p:sp>
+      <p:sp>
+        <p:nvSpPr>
+          <p:cNvPr id="141" name="Heading right"/>
+          <p:cNvSpPr/>
+          <p:nvPr/>
+        </p:nvSpPr>
+        <p:spPr>
+          <a:xfrm>
+            <a:off x="7323226" y="1371600"/>
+            <a:ext cx="4289653" cy="213480"/>
+          </a:xfrm>
+          <a:prstGeom prst="rect">
+            <a:avLst/>
+          </a:prstGeom>
+          <a:noFill/>
+          <a:ln w="0">
+            <a:noFill/>
+          </a:ln>
+        </p:spPr>
+        <p:style>
+          <a:lnRef idx="0"/>
+          <a:fillRef idx="0"/>
+          <a:effectRef idx="0"/>
+          <a:fontRef idx="minor"/>
+        </p:style>
+        <p:txBody>
+          <a:bodyPr lIns="0" tIns="0" rIns="0" bIns="0" anchor="t">
+            <a:spAutoFit/>
+          </a:bodyPr>
+          <a:p>
+            <a:pPr defTabSz="914400">
+              <a:lnSpc>
+                <a:spcPct val="100000"/>
+              </a:lnSpc>
+            </a:pPr>
+            <a:r>
+              <a:rPr lang="hu-HU" sz="1400" b="1" u="none" strike="noStrike">
+                <a:solidFill>
+                  <a:srgbClr val="FF3E31"/>
+                </a:solidFill>
+                <a:effectLst/>
+                <a:uFillTx/>
+                <a:latin typeface="Arial"/>
+                <a:ea typeface="DejaVu Sans"/>
+              </a:rPr>
+              <a:t>CURRENT VERSION: MULTILINGUAL</a:t>
+            </a:r>
+            <a:endParaRPr lang="en-US" sz="1400" b="0" u="none" strike="noStrike">
+              <a:solidFill>
+                <a:srgbClr val="FFFFFF"/>
+              </a:solidFill>
+              <a:effectLst/>
+              <a:uFillTx/>
+              <a:latin typeface="Arial"/>
+            </a:endParaRPr>
+          </a:p>
+        </p:txBody>
+      </p:sp>
+      <p:pic>
+        <p:nvPicPr>
+          <p:cNvPr id="142" name="Screenshot earlier prototype" descr="Jupyter chat with the 16 Oct prototype: after the e-mail is given, the reply degenerates into a repetition loop and ends with category None."/>
+          <p:cNvPicPr>
+            <a:picLocks noChangeAspect="1"/>
+          </p:cNvPicPr>
+          <p:nvPr/>
+        </p:nvPicPr>
+        <p:blipFill>
+          <a:blip r:embed="rId2"/>
+          <a:stretch>
+            <a:fillRect/>
+          </a:stretch>
+        </p:blipFill>
+        <p:spPr>
+          <a:xfrm>
+            <a:off x="594360" y="1700784"/>
+            <a:ext cx="5755568" cy="3749039"/>
+          </a:xfrm>
+          <a:prstGeom prst="rect">
+            <a:avLst/>
+          </a:prstGeom>
+          <a:ln w="9525">
+            <a:solidFill>
+              <a:srgbClr val="6F4642"/>
+            </a:solidFill>
+          </a:ln>
+        </p:spPr>
+      </p:pic>
+      <p:pic>
+        <p:nvPicPr>
+          <p:cNvPr id="143" name="Screenshot current version" descr="Streamlit chat with the current Cairnly Assistant: Hungarian, Finnish and English messages each answered in the same language."/>
+          <p:cNvPicPr>
+            <a:picLocks noChangeAspect="1"/>
+          </p:cNvPicPr>
+          <p:nvPr/>
+        </p:nvPicPr>
+        <p:blipFill>
+          <a:blip r:embed="rId3"/>
+          <a:stretch>
+            <a:fillRect/>
+          </a:stretch>
+        </p:blipFill>
+        <p:spPr>
+          <a:xfrm>
+            <a:off x="7323226" y="1700784"/>
+            <a:ext cx="4289653" cy="3749039"/>
+          </a:xfrm>
+          <a:prstGeom prst="rect">
+            <a:avLst/>
+          </a:prstGeom>
+          <a:ln w="9525">
+            <a:solidFill>
+              <a:srgbClr val="6F4642"/>
+            </a:solidFill>
+          </a:ln>
+        </p:spPr>
+      </p:pic>
+      <p:sp>
+        <p:nvSpPr>
+          <p:cNvPr id="75" name="Caption left"/>
+          <p:cNvSpPr/>
+          <p:nvPr/>
+        </p:nvSpPr>
+        <p:spPr>
+          <a:xfrm>
+            <a:off x="594360" y="5541264"/>
+            <a:ext cx="5755568" cy="243720"/>
+          </a:xfrm>
+          <a:prstGeom prst="rect">
+            <a:avLst/>
+          </a:prstGeom>
+          <a:noFill/>
+          <a:ln w="0">
+            <a:noFill/>
+          </a:ln>
+        </p:spPr>
+        <p:style>
+          <a:lnRef idx="0"/>
+          <a:fillRef idx="0"/>
+          <a:effectRef idx="0"/>
+          <a:fontRef idx="minor"/>
+        </p:style>
+        <p:txBody>
+          <a:bodyPr lIns="0" tIns="0" rIns="0" bIns="0" anchor="t">
+            <a:spAutoFit/>
+          </a:bodyPr>
+          <a:p>
+            <a:pPr defTabSz="914400">
+              <a:lnSpc>
+                <a:spcPct val="100000"/>
+              </a:lnSpc>
+            </a:pPr>
+            <a:r>
+              <a:rPr lang="hu-HU" sz="1200" b="0" u="none" strike="noStrike">
+                <a:solidFill>
+                  <a:srgbClr val="6F4642"/>
+                </a:solidFill>
+                <a:effectLst/>
+                <a:uFillTx/>
+                <a:latin typeface="Arial"/>
+                <a:ea typeface="DejaVu Sans"/>
+              </a:rPr>
+              <a:t>Repetition loop: the 1,000-token cap cut the reply before the JSON closed (category = None). Fix: cap raised to 2,500; the e-mail check was removed too.</a:t>
+            </a:r>
+            <a:endParaRPr lang="en-US" sz="1600" b="0" u="none" strike="noStrike">
+              <a:solidFill>
+                <a:srgbClr val="000000"/>
+              </a:solidFill>
+              <a:effectLst/>
+              <a:uFillTx/>
+              <a:latin typeface="Arial"/>
+            </a:endParaRPr>
+          </a:p>
+        </p:txBody>
+      </p:sp>
+      <p:sp>
+        <p:nvSpPr>
+          <p:cNvPr id="75" name="Caption right"/>
+          <p:cNvSpPr/>
+          <p:nvPr/>
+        </p:nvSpPr>
+        <p:spPr>
+          <a:xfrm>
+            <a:off x="7323226" y="5541264"/>
+            <a:ext cx="4289653" cy="243720"/>
+          </a:xfrm>
+          <a:prstGeom prst="rect">
+            <a:avLst/>
+          </a:prstGeom>
+          <a:noFill/>
+          <a:ln w="0">
+            <a:noFill/>
+          </a:ln>
+        </p:spPr>
+        <p:style>
+          <a:lnRef idx="0"/>
+          <a:fillRef idx="0"/>
+          <a:effectRef idx="0"/>
+          <a:fontRef idx="minor"/>
+        </p:style>
+        <p:txBody>
+          <a:bodyPr lIns="0" tIns="0" rIns="0" bIns="0" anchor="t">
+            <a:spAutoFit/>
+          </a:bodyPr>
+          <a:p>
+            <a:pPr defTabSz="914400">
+              <a:lnSpc>
+                <a:spcPct val="100000"/>
+              </a:lnSpc>
+            </a:pPr>
+            <a:r>
+              <a:rPr lang="hu-HU" sz="1200" b="0" u="none" strike="noStrike">
+                <a:solidFill>
+                  <a:srgbClr val="6F4642"/>
+                </a:solidFill>
+                <a:effectLst/>
+                <a:uFillTx/>
+                <a:latin typeface="Arial"/>
+                <a:ea typeface="DejaVu Sans"/>
+              </a:rPr>
+              <a:t>Hungarian, Finnish and English in one chat: each reply follows the customer's language; the order number alone is enough.</a:t>
+            </a:r>
+            <a:endParaRPr lang="en-US" sz="1600" b="0" u="none" strike="noStrike">
+              <a:solidFill>
+                <a:srgbClr val="000000"/>
+              </a:solidFill>
+              <a:effectLst/>
+              <a:uFillTx/>
+              <a:latin typeface="Arial"/>
+            </a:endParaRPr>
+          </a:p>
+        </p:txBody>
+      </p:sp>
+    </p:spTree>
+  </p:cSld>
+  <p:clrMapOvr>
+    <a:masterClrMapping/>
+  </p:clrMapOvr>
 </p:sld>
 </file>
 

</xml_diff>

<commit_message>
Update project presentation and PDF
Refresh the Cairnly Assistant Group A presentation and its PDF deliverable.
</commit_message>
<xml_diff>
--- a/Cairnly_Assistant_OLLM_Project1_GroupA.pptx
+++ b/Cairnly_Assistant_OLLM_Project1_GroupA.pptx
@@ -13228,64 +13228,6 @@
               <a:t>OWASP-style defences; the read-only tool limits any attack to order statuses.</a:t>
             </a:r>
             <a:endParaRPr lang="en-US" sz="1700" b="0" u="none" strike="noStrike">
-              <a:solidFill>
-                <a:srgbClr val="FFFFFF"/>
-              </a:solidFill>
-              <a:effectLst/>
-              <a:uFillTx/>
-              <a:latin typeface="Arial"/>
-            </a:endParaRPr>
-          </a:p>
-        </p:txBody>
-      </p:sp>
-      <p:sp>
-        <p:nvSpPr>
-          <p:cNvPr id="152" name="TextBox 24"/>
-          <p:cNvSpPr/>
-          <p:nvPr/>
-        </p:nvSpPr>
-        <p:spPr>
-          <a:xfrm>
-            <a:off x="7022520" y="5760720"/>
-            <a:ext cx="4598640" cy="198360"/>
-          </a:xfrm>
-          <a:prstGeom prst="rect">
-            <a:avLst/>
-          </a:prstGeom>
-          <a:noFill/>
-          <a:ln w="0">
-            <a:noFill/>
-          </a:ln>
-        </p:spPr>
-        <p:style>
-          <a:lnRef idx="0"/>
-          <a:fillRef idx="0"/>
-          <a:effectRef idx="0"/>
-          <a:fontRef idx="minor"/>
-        </p:style>
-        <p:txBody>
-          <a:bodyPr lIns="0" tIns="0" rIns="0" bIns="0" anchor="t">
-            <a:spAutoFit/>
-          </a:bodyPr>
-          <a:p>
-            <a:pPr defTabSz="914400">
-              <a:lnSpc>
-                <a:spcPct val="100000"/>
-              </a:lnSpc>
-            </a:pPr>
-            <a:r>
-              <a:rPr lang="hu-HU" sz="1300" b="0" u="none" strike="noStrike">
-                <a:solidFill>
-                  <a:srgbClr val="FDE2DA"/>
-                </a:solidFill>
-                <a:effectLst/>
-                <a:uFillTx/>
-                <a:latin typeface="Arial"/>
-                <a:ea typeface="DejaVu Sans"/>
-              </a:rPr>
-              <a:t>Course prototype only  •  simulated data  •  no live rollout</a:t>
-            </a:r>
-            <a:endParaRPr lang="en-US" sz="1300" b="0" u="none" strike="noStrike">
               <a:solidFill>
                 <a:srgbClr val="FFFFFF"/>
               </a:solidFill>

</xml_diff>